<commit_message>
Deck: fix title wrapping and table spacing after visual QA
</commit_message>
<xml_diff>
--- a/deck/AegisData_Deck.pptx
+++ b/deck/AegisData_Deck.pptx
@@ -2901,8 +2901,8 @@
         </p:nvSpPr>
         <p:spPr>
           <a:xfrm>
-            <a:off x="548640" y="411480"/>
-            <a:ext cx="11064240" cy="685800"/>
+            <a:off x="548640" y="365760"/>
+            <a:ext cx="11064240" cy="731520"/>
           </a:xfrm>
           <a:prstGeom prst="rect">
             <a:avLst/>
@@ -2911,14 +2911,14 @@
           <a:ln/>
         </p:spPr>
         <p:txBody>
-          <a:bodyPr wrap="square" lIns="0" tIns="0" rIns="0" bIns="0" rtlCol="0" anchor="t"/>
+          <a:bodyPr wrap="square" lIns="0" tIns="0" rIns="0" bIns="0" rtlCol="0" anchor="ctr"/>
           <a:lstStyle/>
           <a:p>
             <a:pPr indent="0" marL="0">
               <a:buNone/>
             </a:pPr>
             <a:r>
-              <a:rPr lang="en-US" sz="3200" b="1" dirty="0">
+              <a:rPr lang="en-US" sz="2500" b="1" dirty="0">
                 <a:solidFill>
                   <a:srgbClr val="1E2A44"/>
                 </a:solidFill>
@@ -2928,7 +2928,7 @@
               </a:rPr>
               <a:t>The accountability model is a set of state machines, not a workflow diagram</a:t>
             </a:r>
-            <a:endParaRPr lang="en-US" sz="3200" dirty="0"/>
+            <a:endParaRPr lang="en-US" sz="2500" dirty="0"/>
           </a:p>
         </p:txBody>
       </p:sp>
@@ -2940,7 +2940,7 @@
         </p:nvSpPr>
         <p:spPr>
           <a:xfrm>
-            <a:off x="548640" y="1097280"/>
+            <a:off x="548640" y="1170432"/>
             <a:ext cx="11064240" cy="365760"/>
           </a:xfrm>
           <a:prstGeom prst="rect">
@@ -2957,7 +2957,7 @@
               <a:buNone/>
             </a:pPr>
             <a:r>
-              <a:rPr lang="en-US" sz="1500" i="1" dirty="0">
+              <a:rPr lang="en-US" sz="1400" i="1" dirty="0">
                 <a:solidFill>
                   <a:srgbClr val="475569"/>
                 </a:solidFill>
@@ -2967,7 +2967,7 @@
               </a:rPr>
               <a:t>Every transition is attributable. No state exists for suppress or snooze anywhere in the product.</a:t>
             </a:r>
-            <a:endParaRPr lang="en-US" sz="1500" dirty="0"/>
+            <a:endParaRPr lang="en-US" sz="1400" dirty="0"/>
           </a:p>
         </p:txBody>
       </p:sp>
@@ -5254,8 +5254,8 @@
         </p:nvSpPr>
         <p:spPr>
           <a:xfrm>
-            <a:off x="548640" y="411480"/>
-            <a:ext cx="11064240" cy="685800"/>
+            <a:off x="548640" y="365760"/>
+            <a:ext cx="11064240" cy="731520"/>
           </a:xfrm>
           <a:prstGeom prst="rect">
             <a:avLst/>
@@ -5264,14 +5264,14 @@
           <a:ln/>
         </p:spPr>
         <p:txBody>
-          <a:bodyPr wrap="square" lIns="0" tIns="0" rIns="0" bIns="0" rtlCol="0" anchor="t"/>
+          <a:bodyPr wrap="square" lIns="0" tIns="0" rIns="0" bIns="0" rtlCol="0" anchor="ctr"/>
           <a:lstStyle/>
           <a:p>
             <a:pPr indent="0" marL="0">
               <a:buNone/>
             </a:pPr>
             <a:r>
-              <a:rPr lang="en-US" sz="3200" b="1" dirty="0">
+              <a:rPr lang="en-US" sz="2500" b="1" dirty="0">
                 <a:solidFill>
                   <a:srgbClr val="1E2A44"/>
                 </a:solidFill>
@@ -5281,7 +5281,7 @@
               </a:rPr>
               <a:t>Lead with hybrid-SaaS. Offer on-premises as a defined variant.</a:t>
             </a:r>
-            <a:endParaRPr lang="en-US" sz="3200" dirty="0"/>
+            <a:endParaRPr lang="en-US" sz="2500" dirty="0"/>
           </a:p>
         </p:txBody>
       </p:sp>
@@ -5293,7 +5293,7 @@
         </p:nvSpPr>
         <p:spPr>
           <a:xfrm>
-            <a:off x="548640" y="1097280"/>
+            <a:off x="548640" y="1170432"/>
             <a:ext cx="11064240" cy="365760"/>
           </a:xfrm>
           <a:prstGeom prst="rect">
@@ -5310,7 +5310,7 @@
               <a:buNone/>
             </a:pPr>
             <a:r>
-              <a:rPr lang="en-US" sz="1500" i="1" dirty="0">
+              <a:rPr lang="en-US" sz="1400" i="1" dirty="0">
                 <a:solidFill>
                   <a:srgbClr val="475569"/>
                 </a:solidFill>
@@ -5320,7 +5320,7 @@
               </a:rPr>
               <a:t>Scan-in-place already keeps raw PHI inside the customer. Deployment model only decides where metadata lives.</a:t>
             </a:r>
-            <a:endParaRPr lang="en-US" sz="1500" dirty="0"/>
+            <a:endParaRPr lang="en-US" sz="1400" dirty="0"/>
           </a:p>
         </p:txBody>
       </p:sp>
@@ -5778,8 +5778,8 @@
         </p:nvSpPr>
         <p:spPr>
           <a:xfrm>
-            <a:off x="548640" y="3977640"/>
-            <a:ext cx="11064240" cy="457200"/>
+            <a:off x="548640" y="3931920"/>
+            <a:ext cx="11064240" cy="411480"/>
           </a:xfrm>
           <a:prstGeom prst="rect">
             <a:avLst/>
@@ -5795,7 +5795,7 @@
               <a:buNone/>
             </a:pPr>
             <a:r>
-              <a:rPr lang="en-US" sz="1150" i="1" dirty="0">
+              <a:rPr lang="en-US" sz="1100" i="1" dirty="0">
                 <a:solidFill>
                   <a:srgbClr val="475569"/>
                 </a:solidFill>
@@ -5805,7 +5805,7 @@
               </a:rPr>
               <a:t>Why not pure SaaS: providers with material PHI estates reject any raw-data path leaving the perimeter. Why not on-prem first: it slows time-to-value and multiplies ops burden before product-market fit.</a:t>
             </a:r>
-            <a:endParaRPr lang="en-US" sz="1150" dirty="0"/>
+            <a:endParaRPr lang="en-US" sz="1100" dirty="0"/>
           </a:p>
         </p:txBody>
       </p:sp>
@@ -5824,7 +5824,7 @@
           </p:nvPr>
         </p:nvGraphicFramePr>
         <p:xfrm>
-          <a:off x="548640" y="4526280"/>
+          <a:off x="548640" y="4389120"/>
           <a:ext cx="11064240" cy="914400"/>
         </p:xfrm>
         <a:graphic>
@@ -7354,8 +7354,8 @@
         </p:nvSpPr>
         <p:spPr>
           <a:xfrm>
-            <a:off x="548640" y="411480"/>
-            <a:ext cx="11064240" cy="685800"/>
+            <a:off x="548640" y="365760"/>
+            <a:ext cx="11064240" cy="731520"/>
           </a:xfrm>
           <a:prstGeom prst="rect">
             <a:avLst/>
@@ -7364,14 +7364,14 @@
           <a:ln/>
         </p:spPr>
         <p:txBody>
-          <a:bodyPr wrap="square" lIns="0" tIns="0" rIns="0" bIns="0" rtlCol="0" anchor="t"/>
+          <a:bodyPr wrap="square" lIns="0" tIns="0" rIns="0" bIns="0" rtlCol="0" anchor="ctr"/>
           <a:lstStyle/>
           <a:p>
             <a:pPr indent="0" marL="0">
               <a:buNone/>
             </a:pPr>
             <a:r>
-              <a:rPr lang="en-US" sz="3200" b="1" dirty="0">
+              <a:rPr lang="en-US" sz="2500" b="1" dirty="0">
                 <a:solidFill>
                   <a:srgbClr val="1E2A44"/>
                 </a:solidFill>
@@ -7381,7 +7381,7 @@
               </a:rPr>
               <a:t>Compliance is generated from the same catalogue, not a separate pipeline</a:t>
             </a:r>
-            <a:endParaRPr lang="en-US" sz="3200" dirty="0"/>
+            <a:endParaRPr lang="en-US" sz="2500" dirty="0"/>
           </a:p>
         </p:txBody>
       </p:sp>
@@ -7393,7 +7393,7 @@
         </p:nvSpPr>
         <p:spPr>
           <a:xfrm>
-            <a:off x="548640" y="1097280"/>
+            <a:off x="548640" y="1170432"/>
             <a:ext cx="11064240" cy="365760"/>
           </a:xfrm>
           <a:prstGeom prst="rect">
@@ -7410,7 +7410,7 @@
               <a:buNone/>
             </a:pPr>
             <a:r>
-              <a:rPr lang="en-US" sz="1500" i="1" dirty="0">
+              <a:rPr lang="en-US" sz="1400" i="1" dirty="0">
                 <a:solidFill>
                   <a:srgbClr val="475569"/>
                 </a:solidFill>
@@ -7420,7 +7420,7 @@
               </a:rPr>
               <a:t>Each requirement maps to one capability and one evidence artifact. The prototype fills the status column live.</a:t>
             </a:r>
-            <a:endParaRPr lang="en-US" sz="1500" dirty="0"/>
+            <a:endParaRPr lang="en-US" sz="1400" dirty="0"/>
           </a:p>
         </p:txBody>
       </p:sp>
@@ -10060,8 +10060,8 @@
         </p:nvSpPr>
         <p:spPr>
           <a:xfrm>
-            <a:off x="548640" y="411480"/>
-            <a:ext cx="11064240" cy="685800"/>
+            <a:off x="548640" y="365760"/>
+            <a:ext cx="11064240" cy="731520"/>
           </a:xfrm>
           <a:prstGeom prst="rect">
             <a:avLst/>
@@ -10070,14 +10070,14 @@
           <a:ln/>
         </p:spPr>
         <p:txBody>
-          <a:bodyPr wrap="square" lIns="0" tIns="0" rIns="0" bIns="0" rtlCol="0" anchor="t"/>
+          <a:bodyPr wrap="square" lIns="0" tIns="0" rIns="0" bIns="0" rtlCol="0" anchor="ctr"/>
           <a:lstStyle/>
           <a:p>
             <a:pPr indent="0" marL="0">
               <a:buNone/>
             </a:pPr>
             <a:r>
-              <a:rPr lang="en-US" sz="3200" b="1" dirty="0">
+              <a:rPr lang="en-US" sz="2500" b="1" dirty="0">
                 <a:solidFill>
                   <a:srgbClr val="1E2A44"/>
                 </a:solidFill>
@@ -10087,7 +10087,7 @@
               </a:rPr>
               <a:t>Roadmap: validate the loop, then make the healthcare product real, then assure at scale</a:t>
             </a:r>
-            <a:endParaRPr lang="en-US" sz="3200" dirty="0"/>
+            <a:endParaRPr lang="en-US" sz="2500" dirty="0"/>
           </a:p>
         </p:txBody>
       </p:sp>
@@ -10099,7 +10099,7 @@
         </p:nvSpPr>
         <p:spPr>
           <a:xfrm>
-            <a:off x="548640" y="1097280"/>
+            <a:off x="548640" y="1170432"/>
             <a:ext cx="11064240" cy="365760"/>
           </a:xfrm>
           <a:prstGeom prst="rect">
@@ -10116,7 +10116,7 @@
               <a:buNone/>
             </a:pPr>
             <a:r>
-              <a:rPr lang="en-US" sz="1500" i="1" dirty="0">
+              <a:rPr lang="en-US" sz="1400" i="1" dirty="0">
                 <a:solidFill>
                   <a:srgbClr val="475569"/>
                 </a:solidFill>
@@ -10126,7 +10126,7 @@
               </a:rPr>
               <a:t>Phasing is capability-led. Each phase states what ships, what is deferred, and why.</a:t>
             </a:r>
-            <a:endParaRPr lang="en-US" sz="1500" dirty="0"/>
+            <a:endParaRPr lang="en-US" sz="1400" dirty="0"/>
           </a:p>
         </p:txBody>
       </p:sp>
@@ -11111,8 +11111,8 @@
         </p:nvSpPr>
         <p:spPr>
           <a:xfrm>
-            <a:off x="548640" y="411480"/>
-            <a:ext cx="11064240" cy="685800"/>
+            <a:off x="548640" y="365760"/>
+            <a:ext cx="11064240" cy="731520"/>
           </a:xfrm>
           <a:prstGeom prst="rect">
             <a:avLst/>
@@ -11121,7 +11121,7 @@
           <a:ln/>
         </p:spPr>
         <p:txBody>
-          <a:bodyPr wrap="square" lIns="0" tIns="0" rIns="0" bIns="0" rtlCol="0" anchor="t"/>
+          <a:bodyPr wrap="square" lIns="0" tIns="0" rIns="0" bIns="0" rtlCol="0" anchor="ctr"/>
           <a:lstStyle/>
           <a:p>
             <a:pPr indent="0" marL="0">
@@ -11150,7 +11150,7 @@
         </p:nvSpPr>
         <p:spPr>
           <a:xfrm>
-            <a:off x="548640" y="1097280"/>
+            <a:off x="548640" y="1170432"/>
             <a:ext cx="11064240" cy="365760"/>
           </a:xfrm>
           <a:prstGeom prst="rect">
@@ -11167,7 +11167,7 @@
               <a:buNone/>
             </a:pPr>
             <a:r>
-              <a:rPr lang="en-US" sz="1500" i="1" dirty="0">
+              <a:rPr lang="en-US" sz="1400" i="1" dirty="0">
                 <a:solidFill>
                   <a:srgbClr val="475569"/>
                 </a:solidFill>
@@ -11177,7 +11177,7 @@
               </a:rPr>
               <a:t>A discovery-volume metric rewards finding more. This one rewards closing the loop.</a:t>
             </a:r>
-            <a:endParaRPr lang="en-US" sz="1500" dirty="0"/>
+            <a:endParaRPr lang="en-US" sz="1400" dirty="0"/>
           </a:p>
         </p:txBody>
       </p:sp>
@@ -11754,8 +11754,8 @@
         </p:nvSpPr>
         <p:spPr>
           <a:xfrm>
-            <a:off x="548640" y="411480"/>
-            <a:ext cx="11064240" cy="685800"/>
+            <a:off x="548640" y="365760"/>
+            <a:ext cx="11064240" cy="731520"/>
           </a:xfrm>
           <a:prstGeom prst="rect">
             <a:avLst/>
@@ -11764,7 +11764,7 @@
           <a:ln/>
         </p:spPr>
         <p:txBody>
-          <a:bodyPr wrap="square" lIns="0" tIns="0" rIns="0" bIns="0" rtlCol="0" anchor="t"/>
+          <a:bodyPr wrap="square" lIns="0" tIns="0" rIns="0" bIns="0" rtlCol="0" anchor="ctr"/>
           <a:lstStyle/>
           <a:p>
             <a:pPr indent="0" marL="0">
@@ -11793,7 +11793,7 @@
         </p:nvSpPr>
         <p:spPr>
           <a:xfrm>
-            <a:off x="548640" y="1097280"/>
+            <a:off x="548640" y="1170432"/>
             <a:ext cx="11064240" cy="365760"/>
           </a:xfrm>
           <a:prstGeom prst="rect">
@@ -11810,7 +11810,7 @@
               <a:buNone/>
             </a:pPr>
             <a:r>
-              <a:rPr lang="en-US" sz="1500" i="1" dirty="0">
+              <a:rPr lang="en-US" sz="1400" i="1" dirty="0">
                 <a:solidFill>
                   <a:srgbClr val="CBD5E1"/>
                 </a:solidFill>
@@ -11820,7 +11820,7 @@
               </a:rPr>
               <a:t>Well-flagged assumptions are a strength. These are the ones that change the plan if wrong.</a:t>
             </a:r>
-            <a:endParaRPr lang="en-US" sz="1500" dirty="0"/>
+            <a:endParaRPr lang="en-US" sz="1400" dirty="0"/>
           </a:p>
         </p:txBody>
       </p:sp>
@@ -12565,8 +12565,8 @@
         </p:nvSpPr>
         <p:spPr>
           <a:xfrm>
-            <a:off x="548640" y="411480"/>
-            <a:ext cx="11064240" cy="685800"/>
+            <a:off x="548640" y="365760"/>
+            <a:ext cx="11064240" cy="731520"/>
           </a:xfrm>
           <a:prstGeom prst="rect">
             <a:avLst/>
@@ -12575,14 +12575,14 @@
           <a:ln/>
         </p:spPr>
         <p:txBody>
-          <a:bodyPr wrap="square" lIns="0" tIns="0" rIns="0" bIns="0" rtlCol="0" anchor="t"/>
+          <a:bodyPr wrap="square" lIns="0" tIns="0" rIns="0" bIns="0" rtlCol="0" anchor="ctr"/>
           <a:lstStyle/>
           <a:p>
             <a:pPr indent="0" marL="0">
               <a:buNone/>
             </a:pPr>
             <a:r>
-              <a:rPr lang="en-US" sz="3200" b="1" dirty="0">
+              <a:rPr lang="en-US" sz="2500" b="1" dirty="0">
                 <a:solidFill>
                   <a:srgbClr val="1E2A44"/>
                 </a:solidFill>
@@ -12592,7 +12592,7 @@
               </a:rPr>
               <a:t>Healthcare cannot answer four basic questions about its regulated data</a:t>
             </a:r>
-            <a:endParaRPr lang="en-US" sz="3200" dirty="0"/>
+            <a:endParaRPr lang="en-US" sz="2500" dirty="0"/>
           </a:p>
         </p:txBody>
       </p:sp>
@@ -12604,7 +12604,7 @@
         </p:nvSpPr>
         <p:spPr>
           <a:xfrm>
-            <a:off x="548640" y="1097280"/>
+            <a:off x="548640" y="1170432"/>
             <a:ext cx="11064240" cy="365760"/>
           </a:xfrm>
           <a:prstGeom prst="rect">
@@ -12621,7 +12621,7 @@
               <a:buNone/>
             </a:pPr>
             <a:r>
-              <a:rPr lang="en-US" sz="1500" i="1" dirty="0">
+              <a:rPr lang="en-US" sz="1400" i="1" dirty="0">
                 <a:solidFill>
                   <a:srgbClr val="475569"/>
                 </a:solidFill>
@@ -12631,7 +12631,7 @@
               </a:rPr>
               <a:t>PHI, payment, genetic and minors' data is spread across EMRs, imaging, claims, labs, SaaS and legacy systems.</a:t>
             </a:r>
-            <a:endParaRPr lang="en-US" sz="1500" dirty="0"/>
+            <a:endParaRPr lang="en-US" sz="1400" dirty="0"/>
           </a:p>
         </p:txBody>
       </p:sp>
@@ -13481,7 +13481,7 @@
               <a:buNone/>
             </a:pPr>
             <a:r>
-              <a:rPr lang="en-US" sz="3000" b="1" dirty="0">
+              <a:rPr lang="en-US" sz="2800" b="1" dirty="0">
                 <a:solidFill>
                   <a:srgbClr val="1E2A44"/>
                 </a:solidFill>
@@ -13489,9 +13489,9 @@
                 <a:ea typeface="Cambria" pitchFamily="34" charset="-122"/>
                 <a:cs typeface="Cambria" pitchFamily="34" charset="-120"/>
               </a:rPr>
-              <a:t>≈ ₹225 crore (~$27M)</a:t>
-            </a:r>
-            <a:endParaRPr lang="en-US" sz="3000" dirty="0"/>
+              <a:t>≈ ₹225 cr (~$27M)</a:t>
+            </a:r>
+            <a:endParaRPr lang="en-US" sz="2800" dirty="0"/>
           </a:p>
         </p:txBody>
       </p:sp>
@@ -13684,8 +13684,8 @@
         </p:nvSpPr>
         <p:spPr>
           <a:xfrm>
-            <a:off x="548640" y="411480"/>
-            <a:ext cx="11064240" cy="685800"/>
+            <a:off x="548640" y="365760"/>
+            <a:ext cx="11064240" cy="731520"/>
           </a:xfrm>
           <a:prstGeom prst="rect">
             <a:avLst/>
@@ -13694,7 +13694,7 @@
           <a:ln/>
         </p:spPr>
         <p:txBody>
-          <a:bodyPr wrap="square" lIns="0" tIns="0" rIns="0" bIns="0" rtlCol="0" anchor="t"/>
+          <a:bodyPr wrap="square" lIns="0" tIns="0" rIns="0" bIns="0" rtlCol="0" anchor="ctr"/>
           <a:lstStyle/>
           <a:p>
             <a:pPr indent="0" marL="0">
@@ -13723,7 +13723,7 @@
         </p:nvSpPr>
         <p:spPr>
           <a:xfrm>
-            <a:off x="548640" y="1097280"/>
+            <a:off x="548640" y="1170432"/>
             <a:ext cx="11064240" cy="365760"/>
           </a:xfrm>
           <a:prstGeom prst="rect">
@@ -13740,7 +13740,7 @@
               <a:buNone/>
             </a:pPr>
             <a:r>
-              <a:rPr lang="en-US" sz="1500" i="1" dirty="0">
+              <a:rPr lang="en-US" sz="1400" i="1" dirty="0">
                 <a:solidFill>
                   <a:srgbClr val="475569"/>
                 </a:solidFill>
@@ -13750,7 +13750,7 @@
               </a:rPr>
               <a:t>Discovery and classification are table stakes. The unowned workflow is what happens next.</a:t>
             </a:r>
-            <a:endParaRPr lang="en-US" sz="1500" dirty="0"/>
+            <a:endParaRPr lang="en-US" sz="1400" dirty="0"/>
           </a:p>
         </p:txBody>
       </p:sp>
@@ -15790,8 +15790,8 @@
         </p:nvSpPr>
         <p:spPr>
           <a:xfrm>
-            <a:off x="548640" y="411480"/>
-            <a:ext cx="11064240" cy="685800"/>
+            <a:off x="548640" y="365760"/>
+            <a:ext cx="11064240" cy="731520"/>
           </a:xfrm>
           <a:prstGeom prst="rect">
             <a:avLst/>
@@ -15800,7 +15800,7 @@
           <a:ln/>
         </p:spPr>
         <p:txBody>
-          <a:bodyPr wrap="square" lIns="0" tIns="0" rIns="0" bIns="0" rtlCol="0" anchor="t"/>
+          <a:bodyPr wrap="square" lIns="0" tIns="0" rIns="0" bIns="0" rtlCol="0" anchor="ctr"/>
           <a:lstStyle/>
           <a:p>
             <a:pPr indent="0" marL="0">
@@ -15829,7 +15829,7 @@
         </p:nvSpPr>
         <p:spPr>
           <a:xfrm>
-            <a:off x="548640" y="1097280"/>
+            <a:off x="548640" y="1170432"/>
             <a:ext cx="11064240" cy="365760"/>
           </a:xfrm>
           <a:prstGeom prst="rect">
@@ -15846,7 +15846,7 @@
               <a:buNone/>
             </a:pPr>
             <a:r>
-              <a:rPr lang="en-US" sz="1500" i="1" dirty="0">
+              <a:rPr lang="en-US" sz="1400" i="1" dirty="0">
                 <a:solidFill>
                   <a:srgbClr val="475569"/>
                 </a:solidFill>
@@ -15856,7 +15856,7 @@
               </a:rPr>
               <a:t>Each is a product decision with a trade-off, and each is visible in the prototype.</a:t>
             </a:r>
-            <a:endParaRPr lang="en-US" sz="1500" dirty="0"/>
+            <a:endParaRPr lang="en-US" sz="1400" dirty="0"/>
           </a:p>
         </p:txBody>
       </p:sp>
@@ -16792,8 +16792,8 @@
         </p:nvSpPr>
         <p:spPr>
           <a:xfrm>
-            <a:off x="548640" y="411480"/>
-            <a:ext cx="11064240" cy="685800"/>
+            <a:off x="548640" y="365760"/>
+            <a:ext cx="11064240" cy="731520"/>
           </a:xfrm>
           <a:prstGeom prst="rect">
             <a:avLst/>
@@ -16802,14 +16802,14 @@
           <a:ln/>
         </p:spPr>
         <p:txBody>
-          <a:bodyPr wrap="square" lIns="0" tIns="0" rIns="0" bIns="0" rtlCol="0" anchor="t"/>
+          <a:bodyPr wrap="square" lIns="0" tIns="0" rIns="0" bIns="0" rtlCol="0" anchor="ctr"/>
           <a:lstStyle/>
           <a:p>
             <a:pPr indent="0" marL="0">
               <a:buNone/>
             </a:pPr>
             <a:r>
-              <a:rPr lang="en-US" sz="3200" b="1" dirty="0">
+              <a:rPr lang="en-US" sz="2500" b="1" dirty="0">
                 <a:solidFill>
                   <a:srgbClr val="1E2A44"/>
                 </a:solidFill>
@@ -16819,7 +16819,7 @@
               </a:rPr>
               <a:t>Five personas share one data graph. Nobody gets a dashboard with role toggles.</a:t>
             </a:r>
-            <a:endParaRPr lang="en-US" sz="3200" dirty="0"/>
+            <a:endParaRPr lang="en-US" sz="2500" dirty="0"/>
           </a:p>
         </p:txBody>
       </p:sp>
@@ -16831,7 +16831,7 @@
         </p:nvSpPr>
         <p:spPr>
           <a:xfrm>
-            <a:off x="548640" y="1097280"/>
+            <a:off x="548640" y="1170432"/>
             <a:ext cx="11064240" cy="365760"/>
           </a:xfrm>
           <a:prstGeom prst="rect">
@@ -16848,7 +16848,7 @@
               <a:buNone/>
             </a:pPr>
             <a:r>
-              <a:rPr lang="en-US" sz="1500" i="1" dirty="0">
+              <a:rPr lang="en-US" sz="1400" i="1" dirty="0">
                 <a:solidFill>
                   <a:srgbClr val="475569"/>
                 </a:solidFill>
@@ -16858,7 +16858,7 @@
               </a:rPr>
               <a:t>Personas are accountability responsibilities, not job titles. Each lands on a surface that answers its one question.</a:t>
             </a:r>
-            <a:endParaRPr lang="en-US" sz="1500" dirty="0"/>
+            <a:endParaRPr lang="en-US" sz="1400" dirty="0"/>
           </a:p>
         </p:txBody>
       </p:sp>
@@ -19473,8 +19473,8 @@
         </p:nvSpPr>
         <p:spPr>
           <a:xfrm>
-            <a:off x="548640" y="411480"/>
-            <a:ext cx="11064240" cy="685800"/>
+            <a:off x="548640" y="365760"/>
+            <a:ext cx="11064240" cy="731520"/>
           </a:xfrm>
           <a:prstGeom prst="rect">
             <a:avLst/>
@@ -19483,7 +19483,7 @@
           <a:ln/>
         </p:spPr>
         <p:txBody>
-          <a:bodyPr wrap="square" lIns="0" tIns="0" rIns="0" bIns="0" rtlCol="0" anchor="t"/>
+          <a:bodyPr wrap="square" lIns="0" tIns="0" rIns="0" bIns="0" rtlCol="0" anchor="ctr"/>
           <a:lstStyle/>
           <a:p>
             <a:pPr indent="0" marL="0">
@@ -19512,7 +19512,7 @@
         </p:nvSpPr>
         <p:spPr>
           <a:xfrm>
-            <a:off x="548640" y="1097280"/>
+            <a:off x="548640" y="1170432"/>
             <a:ext cx="11064240" cy="365760"/>
           </a:xfrm>
           <a:prstGeom prst="rect">
@@ -19529,7 +19529,7 @@
               <a:buNone/>
             </a:pPr>
             <a:r>
-              <a:rPr lang="en-US" sz="1500" i="1" dirty="0">
+              <a:rPr lang="en-US" sz="1400" i="1" dirty="0">
                 <a:solidFill>
                   <a:srgbClr val="CBD5E1"/>
                 </a:solidFill>
@@ -19539,7 +19539,7 @@
               </a:rPr>
               <a:t>The Verified-Closed Rate on the CISO's screen should move by the end. Nothing in it is hardcoded.</a:t>
             </a:r>
-            <a:endParaRPr lang="en-US" sz="1500" dirty="0"/>
+            <a:endParaRPr lang="en-US" sz="1400" dirty="0"/>
           </a:p>
         </p:txBody>
       </p:sp>
@@ -20668,8 +20668,8 @@
         </p:nvSpPr>
         <p:spPr>
           <a:xfrm>
-            <a:off x="548640" y="411480"/>
-            <a:ext cx="11064240" cy="685800"/>
+            <a:off x="548640" y="365760"/>
+            <a:ext cx="11064240" cy="731520"/>
           </a:xfrm>
           <a:prstGeom prst="rect">
             <a:avLst/>
@@ -20678,7 +20678,7 @@
           <a:ln/>
         </p:spPr>
         <p:txBody>
-          <a:bodyPr wrap="square" lIns="0" tIns="0" rIns="0" bIns="0" rtlCol="0" anchor="t"/>
+          <a:bodyPr wrap="square" lIns="0" tIns="0" rIns="0" bIns="0" rtlCol="0" anchor="ctr"/>
           <a:lstStyle/>
           <a:p>
             <a:pPr indent="0" marL="0">
@@ -20707,7 +20707,7 @@
         </p:nvSpPr>
         <p:spPr>
           <a:xfrm>
-            <a:off x="548640" y="1097280"/>
+            <a:off x="548640" y="1170432"/>
             <a:ext cx="11064240" cy="365760"/>
           </a:xfrm>
           <a:prstGeom prst="rect">
@@ -20724,7 +20724,7 @@
               <a:buNone/>
             </a:pPr>
             <a:r>
-              <a:rPr lang="en-US" sz="1500" i="1" dirty="0">
+              <a:rPr lang="en-US" sz="1400" i="1" dirty="0">
                 <a:solidFill>
                   <a:srgbClr val="475569"/>
                 </a:solidFill>
@@ -20734,7 +20734,7 @@
               </a:rPr>
               <a:t>Stateless connectors, scanners and classifiers scale out. The metadata catalogue is the single stateful system of record.</a:t>
             </a:r>
-            <a:endParaRPr lang="en-US" sz="1500" dirty="0"/>
+            <a:endParaRPr lang="en-US" sz="1400" dirty="0"/>
           </a:p>
         </p:txBody>
       </p:sp>
@@ -21680,8 +21680,8 @@
         </p:nvSpPr>
         <p:spPr>
           <a:xfrm>
-            <a:off x="548640" y="411480"/>
-            <a:ext cx="11064240" cy="685800"/>
+            <a:off x="548640" y="365760"/>
+            <a:ext cx="11064240" cy="731520"/>
           </a:xfrm>
           <a:prstGeom prst="rect">
             <a:avLst/>
@@ -21690,7 +21690,7 @@
           <a:ln/>
         </p:spPr>
         <p:txBody>
-          <a:bodyPr wrap="square" lIns="0" tIns="0" rIns="0" bIns="0" rtlCol="0" anchor="t"/>
+          <a:bodyPr wrap="square" lIns="0" tIns="0" rIns="0" bIns="0" rtlCol="0" anchor="ctr"/>
           <a:lstStyle/>
           <a:p>
             <a:pPr indent="0" marL="0">
@@ -21719,7 +21719,7 @@
         </p:nvSpPr>
         <p:spPr>
           <a:xfrm>
-            <a:off x="548640" y="1097280"/>
+            <a:off x="548640" y="1170432"/>
             <a:ext cx="11064240" cy="365760"/>
           </a:xfrm>
           <a:prstGeom prst="rect">
@@ -21736,7 +21736,7 @@
               <a:buNone/>
             </a:pPr>
             <a:r>
-              <a:rPr lang="en-US" sz="1500" i="1" dirty="0">
+              <a:rPr lang="en-US" sz="1400" i="1" dirty="0">
                 <a:solidFill>
                   <a:srgbClr val="475569"/>
                 </a:solidFill>
@@ -21746,7 +21746,7 @@
               </a:rPr>
               <a:t>A hard technical control, not a configuration toggle. The customer never surrenders raw PHI to see its risk.</a:t>
             </a:r>
-            <a:endParaRPr lang="en-US" sz="1500" dirty="0"/>
+            <a:endParaRPr lang="en-US" sz="1400" dirty="0"/>
           </a:p>
         </p:txBody>
       </p:sp>
@@ -22894,8 +22894,8 @@
         </p:nvSpPr>
         <p:spPr>
           <a:xfrm>
-            <a:off x="548640" y="411480"/>
-            <a:ext cx="11064240" cy="685800"/>
+            <a:off x="548640" y="365760"/>
+            <a:ext cx="11064240" cy="731520"/>
           </a:xfrm>
           <a:prstGeom prst="rect">
             <a:avLst/>
@@ -22904,14 +22904,14 @@
           <a:ln/>
         </p:spPr>
         <p:txBody>
-          <a:bodyPr wrap="square" lIns="0" tIns="0" rIns="0" bIns="0" rtlCol="0" anchor="t"/>
+          <a:bodyPr wrap="square" lIns="0" tIns="0" rIns="0" bIns="0" rtlCol="0" anchor="ctr"/>
           <a:lstStyle/>
           <a:p>
             <a:pPr indent="0" marL="0">
               <a:buNone/>
             </a:pPr>
             <a:r>
-              <a:rPr lang="en-US" sz="3200" b="1" dirty="0">
+              <a:rPr lang="en-US" sz="2500" b="1" dirty="0">
                 <a:solidFill>
                   <a:srgbClr val="1E2A44"/>
                 </a:solidFill>
@@ -22921,7 +22921,7 @@
               </a:rPr>
               <a:t>Layered classification: cheap and deterministic first, expensive inference last</a:t>
             </a:r>
-            <a:endParaRPr lang="en-US" sz="3200" dirty="0"/>
+            <a:endParaRPr lang="en-US" sz="2500" dirty="0"/>
           </a:p>
         </p:txBody>
       </p:sp>
@@ -22933,7 +22933,7 @@
         </p:nvSpPr>
         <p:spPr>
           <a:xfrm>
-            <a:off x="548640" y="1097280"/>
+            <a:off x="548640" y="1170432"/>
             <a:ext cx="11064240" cy="365760"/>
           </a:xfrm>
           <a:prstGeom prst="rect">
@@ -22950,7 +22950,7 @@
               <a:buNone/>
             </a:pPr>
             <a:r>
-              <a:rPr lang="en-US" sz="1500" i="1" dirty="0">
+              <a:rPr lang="en-US" sz="1400" i="1" dirty="0">
                 <a:solidFill>
                   <a:srgbClr val="475569"/>
                 </a:solidFill>
@@ -22960,7 +22960,7 @@
               </a:rPr>
               <a:t>Layers 1–4 run on everything. Only ambiguous residue escalates to NER, then to a self-hosted LLM.</a:t>
             </a:r>
-            <a:endParaRPr lang="en-US" sz="1500" dirty="0"/>
+            <a:endParaRPr lang="en-US" sz="1400" dirty="0"/>
           </a:p>
         </p:txBody>
       </p:sp>

</xml_diff>

<commit_message>
P0 operational layer: Task Decision Engine, assignment acceptance, four SLA clocks, auto-escalation, action recording, pause treatment, verification reopen, task timeline; Netlify one-command deploy
</commit_message>
<xml_diff>
--- a/deck/AegisData_Deck.pptx
+++ b/deck/AegisData_Deck.pptx
@@ -19667,7 +19667,7 @@
                 <a:ea typeface="Calibri" pitchFamily="34" charset="-122"/>
                 <a:cs typeface="Calibri" pitchFamily="34" charset="-120"/>
               </a:rPr>
-              <a:t>OPS</a:t>
+              <a:t>ANL</a:t>
             </a:r>
             <a:endParaRPr lang="en-US" sz="1400" dirty="0"/>
           </a:p>
@@ -19706,7 +19706,7 @@
                 <a:ea typeface="Calibri" pitchFamily="34" charset="-122"/>
                 <a:cs typeface="Calibri" pitchFamily="34" charset="-120"/>
               </a:rPr>
-              <a:t>Restore a degraded connector. The coverage gap closes but the record stays.</a:t>
+              <a:t>Open Why P0: risk 94/100, factors, Critical Exposure Policy v1.2. Confirm classification. The Task Decision Engine creates the task with four SLA clocks.</a:t>
             </a:r>
             <a:endParaRPr lang="en-US" sz="1200" dirty="0"/>
           </a:p>
@@ -19836,7 +19836,7 @@
                 <a:ea typeface="Calibri" pitchFamily="34" charset="-122"/>
                 <a:cs typeface="Calibri" pitchFamily="34" charset="-120"/>
               </a:rPr>
-              <a:t>ANL</a:t>
+              <a:t>ANL → OWN</a:t>
             </a:r>
             <a:endParaRPr lang="en-US" sz="1400" dirty="0"/>
           </a:p>
@@ -19875,7 +19875,7 @@
                 <a:ea typeface="Calibri" pitchFamily="34" charset="-122"/>
                 <a:cs typeface="Calibri" pitchFamily="34" charset="-120"/>
               </a:rPr>
-              <a:t>Confirm a card-number finding. The policy engine fires Restricted + External → P0 and opens a task.</a:t>
+              <a:t>Assign owner with reason and scope. Status: Awaiting Acceptance, store still Unowned. Nobody is accountable until acceptance.</a:t>
             </a:r>
             <a:endParaRPr lang="en-US" sz="1200" dirty="0"/>
           </a:p>
@@ -20005,7 +20005,7 @@
                 <a:ea typeface="Calibri" pitchFamily="34" charset="-122"/>
                 <a:cs typeface="Calibri" pitchFamily="34" charset="-120"/>
               </a:rPr>
-              <a:t>ANL → OWN</a:t>
+              <a:t>OWN</a:t>
             </a:r>
             <a:endParaRPr lang="en-US" sz="1400" dirty="0"/>
           </a:p>
@@ -20044,7 +20044,7 @@
                 <a:ea typeface="Calibri" pitchFamily="34" charset="-122"/>
                 <a:cs typeface="Calibri" pitchFamily="34" charset="-120"/>
               </a:rPr>
-              <a:t>Assign an owner. Nothing is accountable until the owner accepts. Then SLA starts.</a:t>
+              <a:t>Accept ownership. The acknowledge clock stops. Record containment; the 30-minute clock stops. Resolution keeps running.</a:t>
             </a:r>
             <a:endParaRPr lang="en-US" sz="1200" dirty="0"/>
           </a:p>
@@ -20213,7 +20213,7 @@
                 <a:ea typeface="Calibri" pitchFamily="34" charset="-122"/>
                 <a:cs typeface="Calibri" pitchFamily="34" charset="-120"/>
               </a:rPr>
-              <a:t>Mark complete moves to Pending Verification only. Run the verification scan. Watch one seeded task fail and reopen.</a:t>
+              <a:t>Pause with reason, next action, review date: the SLA treatment is shown, never silent. Delegate: executor changes, accountability stays.</a:t>
             </a:r>
             <a:endParaRPr lang="en-US" sz="1200" dirty="0"/>
           </a:p>
@@ -20343,7 +20343,7 @@
                 <a:ea typeface="Calibri" pitchFamily="34" charset="-122"/>
                 <a:cs typeface="Calibri" pitchFamily="34" charset="-120"/>
               </a:rPr>
-              <a:t>OWN → POL → CISO</a:t>
+              <a:t>OWN → Verifier</a:t>
             </a:r>
             <a:endParaRPr lang="en-US" sz="1400" dirty="0"/>
           </a:p>
@@ -20382,7 +20382,7 @@
                 <a:ea typeface="Calibri" pitchFamily="34" charset="-122"/>
                 <a:cs typeface="Calibri" pitchFamily="34" charset="-120"/>
               </a:rPr>
-              <a:t>Request a Tier-2 exception. POL approves: 1 of 2. CISO completes it. The requester's button is disabled.</a:t>
+              <a:t>Submit for verification. No Mark Complete exists. One seeded task fails verification and reopens itself. The P0 passes and closes.</a:t>
             </a:r>
             <a:endParaRPr lang="en-US" sz="1200" dirty="0"/>
           </a:p>
@@ -20512,7 +20512,7 @@
                 <a:ea typeface="Calibri" pitchFamily="34" charset="-122"/>
                 <a:cs typeface="Calibri" pitchFamily="34" charset="-120"/>
               </a:rPr>
-              <a:t>Auditor</a:t>
+              <a:t>ANL / CISO</a:t>
             </a:r>
             <a:endParaRPr lang="en-US" sz="1400" dirty="0"/>
           </a:p>
@@ -20551,7 +20551,7 @@
                 <a:ea typeface="Calibri" pitchFamily="34" charset="-122"/>
                 <a:cs typeface="Calibri" pitchFamily="34" charset="-120"/>
               </a:rPr>
-              <a:t>Verify the SHA-256 chain. Every action above is an evidence event. Export writes its own.</a:t>
+              <a:t>Advance the demo clock on an unacknowledged task: At Risk → SLA Breached → escalated to the analyst, then the Security Director. The timeline shows every actor and time.</a:t>
             </a:r>
             <a:endParaRPr lang="en-US" sz="1200" dirty="0"/>
           </a:p>

</xml_diff>